<commit_message>
Module 6 lab: full ICICI Pillar 3 dataset, one Word file per RBI table in filing order
bank_data.json now carries one block per RBI table, DF-1 to DF-18, every real
figure page-cited to the bank's March 2025 disclosure. build_pillar3.py
reconciles the ratios to the published ones before writing anything, then
writes 18 table files in order plus a filing log; tables with no data are
written as stubs that say so. Lab page, card and deck slide 7 updated.

Co-Authored-By: Claude Fable 5.1 <noreply@anthropic.com>
</commit_message>
<xml_diff>
--- a/slides/Module-06-RegTech-Basel-Compliance.pptx
+++ b/slides/Module-06-RegTech-Basel-Compliance.pptx
@@ -11175,7 +11175,7 @@
                 </a:solidFill>
                 <a:latin typeface="Georgia"/>
               </a:rPr>
-              <a:t>One sentence, one Word document, one check</a:t>
+              <a:t>One sentence, eighteen files, one check</a:t>
             </a:r>
           </a:p>
         </p:txBody>
@@ -11313,7 +11313,7 @@
                 </a:solidFill>
                 <a:latin typeface="Georgia"/>
               </a:rPr>
-              <a:t>“Here is a bank's capital, RWA and leverage data in bank_data.json. Compute CET1, Tier 1, total capital, leverage, LCR and NSFR, compare each with the RBI minimum, and write a Pillar 3 disclosure in Word with the DF-2 and DF-18 tables.”</a:t>
+              <a:t>“Here is a bank's Pillar 3 data in bank_data.json, one block per RBI table. Compute the six ratios, check them against what the bank published, and write one Word file per RBI table, DF-1 to DF-18, in filing order, with a filing log.”</a:t>
             </a:r>
           </a:p>
         </p:txBody>
@@ -11468,7 +11468,7 @@
                   <a:srgbClr val="1B2A41"/>
                 </a:solidFill>
               </a:rPr>
-              <a:t>Real data: ICICI Bank's published capital and leverage figures, March 2025</a:t>
+              <a:t>Real data: ICICI Bank's published Pillar 3 figures, one block per table</a:t>
             </a:r>
           </a:p>
         </p:txBody>
@@ -11510,7 +11510,7 @@
                   <a:srgbClr val="1B2A41"/>
                 </a:solidFill>
               </a:rPr>
-              <a:t>Six ratios, each one division</a:t>
+              <a:t>Six ratios, each one division, beside the RBI floor</a:t>
             </a:r>
           </a:p>
         </p:txBody>
@@ -11552,7 +11552,7 @@
                   <a:srgbClr val="1B2A41"/>
                 </a:solidFill>
               </a:rPr>
-              <a:t>Each ratio next to the RBI floor with buffers</a:t>
+              <a:t>One Word file per RBI table, DF-1 to DF-18, written one after another</a:t>
             </a:r>
           </a:p>
         </p:txBody>
@@ -11594,7 +11594,7 @@
                   <a:srgbClr val="1B2A41"/>
                 </a:solidFill>
               </a:rPr>
-              <a:t>A Word document in the RBI table layout, written by python-docx</a:t>
+              <a:t>A filing log, and a stub for any table the data cannot fill</a:t>
             </a:r>
           </a:p>
         </p:txBody>
@@ -11791,7 +11791,7 @@
                   <a:srgbClr val="1B2A41"/>
                 </a:solidFill>
               </a:rPr>
-              <a:t>Your document must land on the same four numbers</a:t>
+              <a:t>Your run must land on the same four, and DF-17 must add up</a:t>
             </a:r>
           </a:p>
         </p:txBody>
@@ -11833,7 +11833,7 @@
                   <a:srgbClr val="1B2A41"/>
                 </a:solidFill>
               </a:rPr>
-              <a:t>A mismatch means a wrong input or a wrong formula</a:t>
+              <a:t>The script checks this before it writes a single file</a:t>
             </a:r>
           </a:p>
         </p:txBody>
@@ -11875,7 +11875,7 @@
                   <a:srgbClr val="1B2A41"/>
                 </a:solidFill>
               </a:rPr>
-              <a:t>A document that does not reconcile is not issued</a:t>
+              <a:t>One mismatch and it stops with nothing filed</a:t>
             </a:r>
           </a:p>
         </p:txBody>
@@ -12030,7 +12030,7 @@
                   <a:srgbClr val="C9D6EE"/>
                 </a:solidFill>
               </a:rPr>
-              <a:t>Swap documents with the next desk</a:t>
+              <a:t>Swap folders with the next desk and open their filing log</a:t>
             </a:r>
           </a:p>
         </p:txBody>

</xml_diff>